<commit_message>
combine Multipath-001 and 002 experiment
</commit_message>
<xml_diff>
--- a/src/multipath/output/001-result0.pptx
+++ b/src/multipath/output/001-result0.pptx
@@ -11,6 +11,9 @@
     <p:sldId id="269" r:id="rId5"/>
     <p:sldId id="270" r:id="rId6"/>
     <p:sldId id="271" r:id="rId7"/>
+    <p:sldId id="272" r:id="rId8"/>
+    <p:sldId id="273" r:id="rId9"/>
+    <p:sldId id="274" r:id="rId10"/>
   </p:sldIdLst>
   <p:sldSz cx="12192000" cy="6858000"/>
   <p:notesSz cx="6858000" cy="9144000"/>
@@ -266,7 +269,7 @@
           <a:p>
             <a:fld id="{F65BDE45-A43B-44ED-A8A4-A0BC352449A2}" type="datetimeFigureOut">
               <a:rPr kumimoji="1" lang="ja-JP" altLang="en-US" smtClean="0"/>
-              <a:t>2026/6/4</a:t>
+              <a:t>2026/6/5</a:t>
             </a:fld>
             <a:endParaRPr kumimoji="1" lang="ja-JP" altLang="en-US"/>
           </a:p>
@@ -466,7 +469,7 @@
           <a:p>
             <a:fld id="{F65BDE45-A43B-44ED-A8A4-A0BC352449A2}" type="datetimeFigureOut">
               <a:rPr kumimoji="1" lang="ja-JP" altLang="en-US" smtClean="0"/>
-              <a:t>2026/6/4</a:t>
+              <a:t>2026/6/5</a:t>
             </a:fld>
             <a:endParaRPr kumimoji="1" lang="ja-JP" altLang="en-US"/>
           </a:p>
@@ -676,7 +679,7 @@
           <a:p>
             <a:fld id="{F65BDE45-A43B-44ED-A8A4-A0BC352449A2}" type="datetimeFigureOut">
               <a:rPr kumimoji="1" lang="ja-JP" altLang="en-US" smtClean="0"/>
-              <a:t>2026/6/4</a:t>
+              <a:t>2026/6/5</a:t>
             </a:fld>
             <a:endParaRPr kumimoji="1" lang="ja-JP" altLang="en-US"/>
           </a:p>
@@ -876,7 +879,7 @@
           <a:p>
             <a:fld id="{F65BDE45-A43B-44ED-A8A4-A0BC352449A2}" type="datetimeFigureOut">
               <a:rPr kumimoji="1" lang="ja-JP" altLang="en-US" smtClean="0"/>
-              <a:t>2026/6/4</a:t>
+              <a:t>2026/6/5</a:t>
             </a:fld>
             <a:endParaRPr kumimoji="1" lang="ja-JP" altLang="en-US"/>
           </a:p>
@@ -1152,7 +1155,7 @@
           <a:p>
             <a:fld id="{F65BDE45-A43B-44ED-A8A4-A0BC352449A2}" type="datetimeFigureOut">
               <a:rPr kumimoji="1" lang="ja-JP" altLang="en-US" smtClean="0"/>
-              <a:t>2026/6/4</a:t>
+              <a:t>2026/6/5</a:t>
             </a:fld>
             <a:endParaRPr kumimoji="1" lang="ja-JP" altLang="en-US"/>
           </a:p>
@@ -1420,7 +1423,7 @@
           <a:p>
             <a:fld id="{F65BDE45-A43B-44ED-A8A4-A0BC352449A2}" type="datetimeFigureOut">
               <a:rPr kumimoji="1" lang="ja-JP" altLang="en-US" smtClean="0"/>
-              <a:t>2026/6/4</a:t>
+              <a:t>2026/6/5</a:t>
             </a:fld>
             <a:endParaRPr kumimoji="1" lang="ja-JP" altLang="en-US"/>
           </a:p>
@@ -1835,7 +1838,7 @@
           <a:p>
             <a:fld id="{F65BDE45-A43B-44ED-A8A4-A0BC352449A2}" type="datetimeFigureOut">
               <a:rPr kumimoji="1" lang="ja-JP" altLang="en-US" smtClean="0"/>
-              <a:t>2026/6/4</a:t>
+              <a:t>2026/6/5</a:t>
             </a:fld>
             <a:endParaRPr kumimoji="1" lang="ja-JP" altLang="en-US"/>
           </a:p>
@@ -1977,7 +1980,7 @@
           <a:p>
             <a:fld id="{F65BDE45-A43B-44ED-A8A4-A0BC352449A2}" type="datetimeFigureOut">
               <a:rPr kumimoji="1" lang="ja-JP" altLang="en-US" smtClean="0"/>
-              <a:t>2026/6/4</a:t>
+              <a:t>2026/6/5</a:t>
             </a:fld>
             <a:endParaRPr kumimoji="1" lang="ja-JP" altLang="en-US"/>
           </a:p>
@@ -2090,7 +2093,7 @@
           <a:p>
             <a:fld id="{F65BDE45-A43B-44ED-A8A4-A0BC352449A2}" type="datetimeFigureOut">
               <a:rPr kumimoji="1" lang="ja-JP" altLang="en-US" smtClean="0"/>
-              <a:t>2026/6/4</a:t>
+              <a:t>2026/6/5</a:t>
             </a:fld>
             <a:endParaRPr kumimoji="1" lang="ja-JP" altLang="en-US"/>
           </a:p>
@@ -2403,7 +2406,7 @@
           <a:p>
             <a:fld id="{F65BDE45-A43B-44ED-A8A4-A0BC352449A2}" type="datetimeFigureOut">
               <a:rPr kumimoji="1" lang="ja-JP" altLang="en-US" smtClean="0"/>
-              <a:t>2026/6/4</a:t>
+              <a:t>2026/6/5</a:t>
             </a:fld>
             <a:endParaRPr kumimoji="1" lang="ja-JP" altLang="en-US"/>
           </a:p>
@@ -2692,7 +2695,7 @@
           <a:p>
             <a:fld id="{F65BDE45-A43B-44ED-A8A4-A0BC352449A2}" type="datetimeFigureOut">
               <a:rPr kumimoji="1" lang="ja-JP" altLang="en-US" smtClean="0"/>
-              <a:t>2026/6/4</a:t>
+              <a:t>2026/6/5</a:t>
             </a:fld>
             <a:endParaRPr kumimoji="1" lang="ja-JP" altLang="en-US"/>
           </a:p>
@@ -2935,7 +2938,7 @@
           <a:p>
             <a:fld id="{F65BDE45-A43B-44ED-A8A4-A0BC352449A2}" type="datetimeFigureOut">
               <a:rPr kumimoji="1" lang="ja-JP" altLang="en-US" smtClean="0"/>
-              <a:t>2026/6/4</a:t>
+              <a:t>2026/6/5</a:t>
             </a:fld>
             <a:endParaRPr kumimoji="1" lang="ja-JP" altLang="en-US"/>
           </a:p>
@@ -7680,6 +7683,530 @@
 </p:sld>
 </file>
 
+<file path=ppt/slides/slide7.xml><?xml version="1.0" encoding="utf-8"?>
+<p:sld xmlns:a="http://schemas.openxmlformats.org/drawingml/2006/main" xmlns:r="http://schemas.openxmlformats.org/officeDocument/2006/relationships" xmlns:p="http://schemas.openxmlformats.org/presentationml/2006/main">
+  <p:cSld>
+    <p:spTree>
+      <p:nvGrpSpPr>
+        <p:cNvPr id="1" name="">
+          <a:extLst>
+            <a:ext uri="{FF2B5EF4-FFF2-40B4-BE49-F238E27FC236}">
+              <a16:creationId xmlns:a16="http://schemas.microsoft.com/office/drawing/2014/main" id="{CFB4B660-D72F-174B-22E6-DDABB07F3B4A}"/>
+            </a:ext>
+          </a:extLst>
+        </p:cNvPr>
+        <p:cNvGrpSpPr/>
+        <p:nvPr/>
+      </p:nvGrpSpPr>
+      <p:grpSpPr>
+        <a:xfrm>
+          <a:off x="0" y="0"/>
+          <a:ext cx="0" cy="0"/>
+          <a:chOff x="0" y="0"/>
+          <a:chExt cx="0" cy="0"/>
+        </a:xfrm>
+      </p:grpSpPr>
+      <p:pic>
+        <p:nvPicPr>
+          <p:cNvPr id="17" name="Picture 16">
+            <a:extLst>
+              <a:ext uri="{FF2B5EF4-FFF2-40B4-BE49-F238E27FC236}">
+                <a16:creationId xmlns:a16="http://schemas.microsoft.com/office/drawing/2014/main" id="{2D2A7874-B117-894F-BDBA-1224B8CA0347}"/>
+              </a:ext>
+            </a:extLst>
+          </p:cNvPr>
+          <p:cNvPicPr>
+            <a:picLocks noChangeAspect="1"/>
+          </p:cNvPicPr>
+          <p:nvPr/>
+        </p:nvPicPr>
+        <p:blipFill>
+          <a:blip r:embed="rId2"/>
+          <a:stretch>
+            <a:fillRect/>
+          </a:stretch>
+        </p:blipFill>
+        <p:spPr>
+          <a:xfrm>
+            <a:off x="7150145" y="979877"/>
+            <a:ext cx="4687978" cy="4681728"/>
+          </a:xfrm>
+          <a:prstGeom prst="rect">
+            <a:avLst/>
+          </a:prstGeom>
+        </p:spPr>
+      </p:pic>
+      <p:pic>
+        <p:nvPicPr>
+          <p:cNvPr id="9" name="Picture 8">
+            <a:extLst>
+              <a:ext uri="{FF2B5EF4-FFF2-40B4-BE49-F238E27FC236}">
+                <a16:creationId xmlns:a16="http://schemas.microsoft.com/office/drawing/2014/main" id="{2CE7F74F-C224-A37C-C39B-BA15DF7042B7}"/>
+              </a:ext>
+            </a:extLst>
+          </p:cNvPr>
+          <p:cNvPicPr>
+            <a:picLocks noChangeAspect="1"/>
+          </p:cNvPicPr>
+          <p:nvPr/>
+        </p:nvPicPr>
+        <p:blipFill>
+          <a:blip r:embed="rId3"/>
+          <a:stretch>
+            <a:fillRect/>
+          </a:stretch>
+        </p:blipFill>
+        <p:spPr>
+          <a:xfrm>
+            <a:off x="769255" y="3320741"/>
+            <a:ext cx="5607161" cy="1164060"/>
+          </a:xfrm>
+          <a:prstGeom prst="rect">
+            <a:avLst/>
+          </a:prstGeom>
+        </p:spPr>
+      </p:pic>
+      <p:pic>
+        <p:nvPicPr>
+          <p:cNvPr id="4" name="Picture 3">
+            <a:extLst>
+              <a:ext uri="{FF2B5EF4-FFF2-40B4-BE49-F238E27FC236}">
+                <a16:creationId xmlns:a16="http://schemas.microsoft.com/office/drawing/2014/main" id="{1BF38AF0-41A0-ED85-CB0A-59B9B32EE26B}"/>
+              </a:ext>
+            </a:extLst>
+          </p:cNvPr>
+          <p:cNvPicPr>
+            <a:picLocks noChangeAspect="1"/>
+          </p:cNvPicPr>
+          <p:nvPr/>
+        </p:nvPicPr>
+        <p:blipFill>
+          <a:blip r:embed="rId4"/>
+          <a:stretch>
+            <a:fillRect/>
+          </a:stretch>
+        </p:blipFill>
+        <p:spPr>
+          <a:xfrm>
+            <a:off x="690008" y="1660620"/>
+            <a:ext cx="5899768" cy="1454167"/>
+          </a:xfrm>
+          <a:prstGeom prst="rect">
+            <a:avLst/>
+          </a:prstGeom>
+        </p:spPr>
+      </p:pic>
+      <p:sp>
+        <p:nvSpPr>
+          <p:cNvPr id="7" name="Right Bracket 6">
+            <a:extLst>
+              <a:ext uri="{FF2B5EF4-FFF2-40B4-BE49-F238E27FC236}">
+                <a16:creationId xmlns:a16="http://schemas.microsoft.com/office/drawing/2014/main" id="{88240A6C-F866-90EF-E63C-59D6C0189679}"/>
+              </a:ext>
+            </a:extLst>
+          </p:cNvPr>
+          <p:cNvSpPr/>
+          <p:nvPr/>
+        </p:nvSpPr>
+        <p:spPr>
+          <a:xfrm flipH="1">
+            <a:off x="471338" y="1758874"/>
+            <a:ext cx="188537" cy="1766750"/>
+          </a:xfrm>
+          <a:prstGeom prst="rightBracket">
+            <a:avLst>
+              <a:gd name="adj" fmla="val 0"/>
+            </a:avLst>
+          </a:prstGeom>
+          <a:ln>
+            <a:solidFill>
+              <a:schemeClr val="tx1"/>
+            </a:solidFill>
+          </a:ln>
+        </p:spPr>
+        <p:style>
+          <a:lnRef idx="1">
+            <a:schemeClr val="accent1"/>
+          </a:lnRef>
+          <a:fillRef idx="0">
+            <a:schemeClr val="accent1"/>
+          </a:fillRef>
+          <a:effectRef idx="0">
+            <a:schemeClr val="accent1"/>
+          </a:effectRef>
+          <a:fontRef idx="minor">
+            <a:schemeClr val="tx1"/>
+          </a:fontRef>
+        </p:style>
+        <p:txBody>
+          <a:bodyPr rtlCol="0" anchor="ctr"/>
+          <a:lstStyle/>
+          <a:p>
+            <a:pPr algn="ctr"/>
+            <a:endParaRPr kumimoji="1" lang="ja-JP" altLang="en-US"/>
+          </a:p>
+        </p:txBody>
+      </p:sp>
+      <p:cxnSp>
+        <p:nvCxnSpPr>
+          <p:cNvPr id="26" name="Straight Connector 25">
+            <a:extLst>
+              <a:ext uri="{FF2B5EF4-FFF2-40B4-BE49-F238E27FC236}">
+                <a16:creationId xmlns:a16="http://schemas.microsoft.com/office/drawing/2014/main" id="{C9B5509C-27A3-E428-E3CF-93793BA4D5EA}"/>
+              </a:ext>
+            </a:extLst>
+          </p:cNvPr>
+          <p:cNvCxnSpPr>
+            <a:cxnSpLocks/>
+          </p:cNvCxnSpPr>
+          <p:nvPr/>
+        </p:nvCxnSpPr>
+        <p:spPr>
+          <a:xfrm>
+            <a:off x="1793301" y="4484801"/>
+            <a:ext cx="0" cy="669905"/>
+          </a:xfrm>
+          <a:prstGeom prst="line">
+            <a:avLst/>
+          </a:prstGeom>
+          <a:ln>
+            <a:solidFill>
+              <a:schemeClr val="tx1"/>
+            </a:solidFill>
+          </a:ln>
+        </p:spPr>
+        <p:style>
+          <a:lnRef idx="1">
+            <a:schemeClr val="accent1"/>
+          </a:lnRef>
+          <a:fillRef idx="0">
+            <a:schemeClr val="accent1"/>
+          </a:fillRef>
+          <a:effectRef idx="0">
+            <a:schemeClr val="accent1"/>
+          </a:effectRef>
+          <a:fontRef idx="minor">
+            <a:schemeClr val="tx1"/>
+          </a:fontRef>
+        </p:style>
+      </p:cxnSp>
+      <p:cxnSp>
+        <p:nvCxnSpPr>
+          <p:cNvPr id="27" name="Straight Arrow Connector 26">
+            <a:extLst>
+              <a:ext uri="{FF2B5EF4-FFF2-40B4-BE49-F238E27FC236}">
+                <a16:creationId xmlns:a16="http://schemas.microsoft.com/office/drawing/2014/main" id="{61BA9644-AC17-824F-65E4-3C90A89D5A16}"/>
+              </a:ext>
+            </a:extLst>
+          </p:cNvPr>
+          <p:cNvCxnSpPr>
+            <a:cxnSpLocks/>
+          </p:cNvCxnSpPr>
+          <p:nvPr/>
+        </p:nvCxnSpPr>
+        <p:spPr>
+          <a:xfrm>
+            <a:off x="1793301" y="5154706"/>
+            <a:ext cx="7494942" cy="0"/>
+          </a:xfrm>
+          <a:prstGeom prst="straightConnector1">
+            <a:avLst/>
+          </a:prstGeom>
+          <a:ln>
+            <a:solidFill>
+              <a:schemeClr val="tx1"/>
+            </a:solidFill>
+            <a:tailEnd type="triangle"/>
+          </a:ln>
+        </p:spPr>
+        <p:style>
+          <a:lnRef idx="1">
+            <a:schemeClr val="accent1"/>
+          </a:lnRef>
+          <a:fillRef idx="0">
+            <a:schemeClr val="accent1"/>
+          </a:fillRef>
+          <a:effectRef idx="0">
+            <a:schemeClr val="accent1"/>
+          </a:effectRef>
+          <a:fontRef idx="minor">
+            <a:schemeClr val="tx1"/>
+          </a:fontRef>
+        </p:style>
+      </p:cxnSp>
+    </p:spTree>
+    <p:extLst>
+      <p:ext uri="{BB962C8B-B14F-4D97-AF65-F5344CB8AC3E}">
+        <p14:creationId xmlns:p14="http://schemas.microsoft.com/office/powerpoint/2010/main" val="510840349"/>
+      </p:ext>
+    </p:extLst>
+  </p:cSld>
+  <p:clrMapOvr>
+    <a:masterClrMapping/>
+  </p:clrMapOvr>
+</p:sld>
+</file>
+
+<file path=ppt/slides/slide8.xml><?xml version="1.0" encoding="utf-8"?>
+<p:sld xmlns:a="http://schemas.openxmlformats.org/drawingml/2006/main" xmlns:r="http://schemas.openxmlformats.org/officeDocument/2006/relationships" xmlns:p="http://schemas.openxmlformats.org/presentationml/2006/main">
+  <p:cSld>
+    <p:spTree>
+      <p:nvGrpSpPr>
+        <p:cNvPr id="1" name="">
+          <a:extLst>
+            <a:ext uri="{FF2B5EF4-FFF2-40B4-BE49-F238E27FC236}">
+              <a16:creationId xmlns:a16="http://schemas.microsoft.com/office/drawing/2014/main" id="{2517EA7C-DDA3-692A-648B-9624DCFF5A30}"/>
+            </a:ext>
+          </a:extLst>
+        </p:cNvPr>
+        <p:cNvGrpSpPr/>
+        <p:nvPr/>
+      </p:nvGrpSpPr>
+      <p:grpSpPr>
+        <a:xfrm>
+          <a:off x="0" y="0"/>
+          <a:ext cx="0" cy="0"/>
+          <a:chOff x="0" y="0"/>
+          <a:chExt cx="0" cy="0"/>
+        </a:xfrm>
+      </p:grpSpPr>
+      <p:pic>
+        <p:nvPicPr>
+          <p:cNvPr id="3" name="Picture 2">
+            <a:extLst>
+              <a:ext uri="{FF2B5EF4-FFF2-40B4-BE49-F238E27FC236}">
+                <a16:creationId xmlns:a16="http://schemas.microsoft.com/office/drawing/2014/main" id="{953110AD-72E5-A58E-0831-A804CDF05318}"/>
+              </a:ext>
+            </a:extLst>
+          </p:cNvPr>
+          <p:cNvPicPr>
+            <a:picLocks noChangeAspect="1"/>
+          </p:cNvPicPr>
+          <p:nvPr/>
+        </p:nvPicPr>
+        <p:blipFill>
+          <a:blip r:embed="rId2"/>
+          <a:stretch>
+            <a:fillRect/>
+          </a:stretch>
+        </p:blipFill>
+        <p:spPr>
+          <a:xfrm>
+            <a:off x="4080335" y="1245681"/>
+            <a:ext cx="4031329" cy="4366638"/>
+          </a:xfrm>
+          <a:prstGeom prst="rect">
+            <a:avLst/>
+          </a:prstGeom>
+        </p:spPr>
+      </p:pic>
+    </p:spTree>
+    <p:extLst>
+      <p:ext uri="{BB962C8B-B14F-4D97-AF65-F5344CB8AC3E}">
+        <p14:creationId xmlns:p14="http://schemas.microsoft.com/office/powerpoint/2010/main" val="4235581625"/>
+      </p:ext>
+    </p:extLst>
+  </p:cSld>
+  <p:clrMapOvr>
+    <a:masterClrMapping/>
+  </p:clrMapOvr>
+</p:sld>
+</file>
+
+<file path=ppt/slides/slide9.xml><?xml version="1.0" encoding="utf-8"?>
+<p:sld xmlns:a="http://schemas.openxmlformats.org/drawingml/2006/main" xmlns:r="http://schemas.openxmlformats.org/officeDocument/2006/relationships" xmlns:p="http://schemas.openxmlformats.org/presentationml/2006/main">
+  <p:cSld>
+    <p:spTree>
+      <p:nvGrpSpPr>
+        <p:cNvPr id="1" name="">
+          <a:extLst>
+            <a:ext uri="{FF2B5EF4-FFF2-40B4-BE49-F238E27FC236}">
+              <a16:creationId xmlns:a16="http://schemas.microsoft.com/office/drawing/2014/main" id="{381C361B-4CDF-5F4D-1C05-2052FC52F936}"/>
+            </a:ext>
+          </a:extLst>
+        </p:cNvPr>
+        <p:cNvGrpSpPr/>
+        <p:nvPr/>
+      </p:nvGrpSpPr>
+      <p:grpSpPr>
+        <a:xfrm>
+          <a:off x="0" y="0"/>
+          <a:ext cx="0" cy="0"/>
+          <a:chOff x="0" y="0"/>
+          <a:chExt cx="0" cy="0"/>
+        </a:xfrm>
+      </p:grpSpPr>
+      <p:pic>
+        <p:nvPicPr>
+          <p:cNvPr id="3" name="Picture 2">
+            <a:extLst>
+              <a:ext uri="{FF2B5EF4-FFF2-40B4-BE49-F238E27FC236}">
+                <a16:creationId xmlns:a16="http://schemas.microsoft.com/office/drawing/2014/main" id="{606CE6E4-E1F0-94CB-FE10-620EB532A908}"/>
+              </a:ext>
+            </a:extLst>
+          </p:cNvPr>
+          <p:cNvPicPr>
+            <a:picLocks noChangeAspect="1"/>
+          </p:cNvPicPr>
+          <p:nvPr/>
+        </p:nvPicPr>
+        <p:blipFill>
+          <a:blip r:embed="rId2">
+            <a:extLst>
+              <a:ext uri="{28A0092B-C50C-407E-A947-70E740481C1C}">
+                <a14:useLocalDpi xmlns:a14="http://schemas.microsoft.com/office/drawing/2010/main" val="0"/>
+              </a:ext>
+            </a:extLst>
+          </a:blip>
+          <a:stretch>
+            <a:fillRect/>
+          </a:stretch>
+        </p:blipFill>
+        <p:spPr>
+          <a:xfrm>
+            <a:off x="263757" y="2135565"/>
+            <a:ext cx="5508396" cy="3061951"/>
+          </a:xfrm>
+          <a:prstGeom prst="rect">
+            <a:avLst/>
+          </a:prstGeom>
+        </p:spPr>
+      </p:pic>
+      <p:pic>
+        <p:nvPicPr>
+          <p:cNvPr id="6" name="Picture 5">
+            <a:extLst>
+              <a:ext uri="{FF2B5EF4-FFF2-40B4-BE49-F238E27FC236}">
+                <a16:creationId xmlns:a16="http://schemas.microsoft.com/office/drawing/2014/main" id="{0AB46D10-B615-AF1C-4CF3-7E7B67FF7943}"/>
+              </a:ext>
+            </a:extLst>
+          </p:cNvPr>
+          <p:cNvPicPr>
+            <a:picLocks noChangeAspect="1"/>
+          </p:cNvPicPr>
+          <p:nvPr/>
+        </p:nvPicPr>
+        <p:blipFill>
+          <a:blip r:embed="rId3">
+            <a:extLst>
+              <a:ext uri="{28A0092B-C50C-407E-A947-70E740481C1C}">
+                <a14:useLocalDpi xmlns:a14="http://schemas.microsoft.com/office/drawing/2010/main" val="0"/>
+              </a:ext>
+            </a:extLst>
+          </a:blip>
+          <a:stretch>
+            <a:fillRect/>
+          </a:stretch>
+        </p:blipFill>
+        <p:spPr>
+          <a:xfrm>
+            <a:off x="6419848" y="2135566"/>
+            <a:ext cx="5508396" cy="3061951"/>
+          </a:xfrm>
+          <a:prstGeom prst="rect">
+            <a:avLst/>
+          </a:prstGeom>
+        </p:spPr>
+      </p:pic>
+      <p:sp>
+        <p:nvSpPr>
+          <p:cNvPr id="7" name="TextBox 6">
+            <a:extLst>
+              <a:ext uri="{FF2B5EF4-FFF2-40B4-BE49-F238E27FC236}">
+                <a16:creationId xmlns:a16="http://schemas.microsoft.com/office/drawing/2014/main" id="{01226B53-3852-1D87-9EFA-40D044305A52}"/>
+              </a:ext>
+            </a:extLst>
+          </p:cNvPr>
+          <p:cNvSpPr txBox="1"/>
+          <p:nvPr/>
+        </p:nvSpPr>
+        <p:spPr>
+          <a:xfrm>
+            <a:off x="2378746" y="1743103"/>
+            <a:ext cx="1756898" cy="338554"/>
+          </a:xfrm>
+          <a:prstGeom prst="rect">
+            <a:avLst/>
+          </a:prstGeom>
+          <a:noFill/>
+        </p:spPr>
+        <p:txBody>
+          <a:bodyPr wrap="square">
+            <a:spAutoFit/>
+          </a:bodyPr>
+          <a:lstStyle/>
+          <a:p>
+            <a:pPr algn="ctr"/>
+            <a:r>
+              <a:rPr lang="en-US" altLang="ja-JP" sz="1600" dirty="0">
+                <a:latin typeface="Arial" panose="020B0604020202020204" pitchFamily="34" charset="0"/>
+                <a:cs typeface="Arial" panose="020B0604020202020204" pitchFamily="34" charset="0"/>
+              </a:rPr>
+              <a:t>Empty Room</a:t>
+            </a:r>
+            <a:endParaRPr lang="ja-JP" altLang="en-US" sz="1600" dirty="0">
+              <a:latin typeface="Arial" panose="020B0604020202020204" pitchFamily="34" charset="0"/>
+              <a:cs typeface="Arial" panose="020B0604020202020204" pitchFamily="34" charset="0"/>
+            </a:endParaRPr>
+          </a:p>
+        </p:txBody>
+      </p:sp>
+      <p:sp>
+        <p:nvSpPr>
+          <p:cNvPr id="8" name="TextBox 7">
+            <a:extLst>
+              <a:ext uri="{FF2B5EF4-FFF2-40B4-BE49-F238E27FC236}">
+                <a16:creationId xmlns:a16="http://schemas.microsoft.com/office/drawing/2014/main" id="{2DE32CFC-DB71-484D-2838-66616CA22A5E}"/>
+              </a:ext>
+            </a:extLst>
+          </p:cNvPr>
+          <p:cNvSpPr txBox="1"/>
+          <p:nvPr/>
+        </p:nvSpPr>
+        <p:spPr>
+          <a:xfrm>
+            <a:off x="8525512" y="1743103"/>
+            <a:ext cx="1756898" cy="338554"/>
+          </a:xfrm>
+          <a:prstGeom prst="rect">
+            <a:avLst/>
+          </a:prstGeom>
+          <a:noFill/>
+        </p:spPr>
+        <p:txBody>
+          <a:bodyPr wrap="square">
+            <a:spAutoFit/>
+          </a:bodyPr>
+          <a:lstStyle/>
+          <a:p>
+            <a:pPr algn="ctr"/>
+            <a:r>
+              <a:rPr lang="en-US" altLang="ja-JP" sz="1600" dirty="0">
+                <a:latin typeface="Arial" panose="020B0604020202020204" pitchFamily="34" charset="0"/>
+                <a:cs typeface="Arial" panose="020B0604020202020204" pitchFamily="34" charset="0"/>
+              </a:rPr>
+              <a:t>Obstacles</a:t>
+            </a:r>
+            <a:endParaRPr lang="ja-JP" altLang="en-US" sz="1600" dirty="0">
+              <a:latin typeface="Arial" panose="020B0604020202020204" pitchFamily="34" charset="0"/>
+              <a:cs typeface="Arial" panose="020B0604020202020204" pitchFamily="34" charset="0"/>
+            </a:endParaRPr>
+          </a:p>
+        </p:txBody>
+      </p:sp>
+    </p:spTree>
+    <p:extLst>
+      <p:ext uri="{BB962C8B-B14F-4D97-AF65-F5344CB8AC3E}">
+        <p14:creationId xmlns:p14="http://schemas.microsoft.com/office/powerpoint/2010/main" val="1658419446"/>
+      </p:ext>
+    </p:extLst>
+  </p:cSld>
+  <p:clrMapOvr>
+    <a:masterClrMapping/>
+  </p:clrMapOvr>
+</p:sld>
+</file>
+
 <file path=ppt/theme/theme1.xml><?xml version="1.0" encoding="utf-8"?>
 <a:theme xmlns:a="http://schemas.openxmlformats.org/drawingml/2006/main" name="Office Theme">
   <a:themeElements>

</xml_diff>